<commit_message>
Finalize portfolio deployment and documentation
</commit_message>
<xml_diff>
--- a/docs/final/Презентація_чернетка.pptx
+++ b/docs/final/Презентація_чернетка.pptx
@@ -21,6 +21,7 @@
     <p:sldId id="269" r:id="rId15"/>
     <p:sldId id="270" r:id="rId16"/>
     <p:sldId id="271" r:id="rId17"/>
+    <p:sldId id="272" r:id="rId18"/>
   </p:sldIdLst>
   <p:sldSz cx="13333333" cy="7500000" type="wide"/>
   <p:notesSz cx="6858000" cy="9144000"/>
@@ -865,7 +866,7 @@
                 <a:latin typeface="Aptos"/>
                 <a:cs typeface="Aptos"/>
               </a:rPr>
-              <a:t>Automated tests: 10 passed.</a:t>
+              <a:t>Automated tests: 13 passed; public dashboard smoke test passed.</a:t>
             </a:r>
           </a:p>
         </p:txBody>
@@ -989,7 +990,7 @@
                 <a:latin typeface="Aptos"/>
                 <a:cs typeface="Aptos"/>
               </a:rPr>
-              <a:t>Why this is an engineering project</a:t>
+              <a:t>Public portfolio deployment</a:t>
             </a:r>
           </a:p>
         </p:txBody>
@@ -1025,52 +1026,52 @@
                 <a:latin typeface="Aptos"/>
                 <a:cs typeface="Aptos"/>
               </a:rPr>
-              <a:t>The project does not claim to invent WFM as a new market category.</a:t>
-            </a:r>
-          </a:p>
-          <a:p>
-            <a:pPr marL="285750" indent="-171450">
-              <a:buChar char="•"/>
-            </a:pPr>
-            <a:r>
-              <a:rPr lang="uk-UA" sz="1900" dirty="0">
-                <a:solidFill>
-                  <a:srgbClr val="263244"/>
-                </a:solidFill>
-                <a:latin typeface="Aptos"/>
-                <a:cs typeface="Aptos"/>
-              </a:rPr>
-              <a:t>Its novelty is the transparent, reproducible, open-data implementation of an enterprise WFM workflow.</a:t>
-            </a:r>
-          </a:p>
-          <a:p>
-            <a:pPr marL="285750" indent="-171450">
-              <a:buChar char="•"/>
-            </a:pPr>
-            <a:r>
-              <a:rPr lang="uk-UA" sz="1900" dirty="0">
-                <a:solidFill>
-                  <a:srgbClr val="263244"/>
-                </a:solidFill>
-                <a:latin typeface="Aptos"/>
-                <a:cs typeface="Aptos"/>
-              </a:rPr>
-              <a:t>Academic value: every layer can be inspected, changed, evaluated and extended.</a:t>
-            </a:r>
-          </a:p>
-          <a:p>
-            <a:pPr marL="285750" indent="-171450">
-              <a:buChar char="•"/>
-            </a:pPr>
-            <a:r>
-              <a:rPr lang="uk-UA" sz="1900" dirty="0">
-                <a:solidFill>
-                  <a:srgbClr val="263244"/>
-                </a:solidFill>
-                <a:latin typeface="Aptos"/>
-                <a:cs typeface="Aptos"/>
-              </a:rPr>
-              <a:t>Market relevance: commercial WFM suites solve the same real operational problem.</a:t>
+              <a:t>Public URL: https://wfm.vartsab.com:8443.</a:t>
+            </a:r>
+          </a:p>
+          <a:p>
+            <a:pPr marL="285750" indent="-171450">
+              <a:buChar char="•"/>
+            </a:pPr>
+            <a:r>
+              <a:rPr lang="uk-UA" sz="1900" dirty="0">
+                <a:solidFill>
+                  <a:srgbClr val="263244"/>
+                </a:solidFill>
+                <a:latin typeface="Aptos"/>
+                <a:cs typeface="Aptos"/>
+              </a:rPr>
+              <a:t>Docker Compose runs PostgreSQL, Streamlit and Caddy on a small VPS.</a:t>
+            </a:r>
+          </a:p>
+          <a:p>
+            <a:pPr marL="285750" indent="-171450">
+              <a:buChar char="•"/>
+            </a:pPr>
+            <a:r>
+              <a:rPr lang="uk-UA" sz="1900" dirty="0">
+                <a:solidFill>
+                  <a:srgbClr val="263244"/>
+                </a:solidFill>
+                <a:latin typeface="Aptos"/>
+                <a:cs typeface="Aptos"/>
+              </a:rPr>
+              <a:t>Caddy provides HTTPS on port 8443 while the existing VPN keeps port 443.</a:t>
+            </a:r>
+          </a:p>
+          <a:p>
+            <a:pPr marL="285750" indent="-171450">
+              <a:buChar char="•"/>
+            </a:pPr>
+            <a:r>
+              <a:rPr lang="uk-UA" sz="1900" dirty="0">
+                <a:solidFill>
+                  <a:srgbClr val="263244"/>
+                </a:solidFill>
+                <a:latin typeface="Aptos"/>
+                <a:cs typeface="Aptos"/>
+              </a:rPr>
+              <a:t>The deployed dashboard uses compact Postgres seed tables and a simple password gate.</a:t>
             </a:r>
           </a:p>
         </p:txBody>
@@ -1172,7 +1173,7 @@
                 <a:latin typeface="Aptos"/>
                 <a:cs typeface="Aptos"/>
               </a:rPr>
-              <a:t>Limitations</a:t>
+              <a:t>Why this is an engineering project</a:t>
             </a:r>
           </a:p>
         </p:txBody>
@@ -1208,52 +1209,52 @@
                 <a:latin typeface="Aptos"/>
                 <a:cs typeface="Aptos"/>
               </a:rPr>
-              <a:t>311 records are public-service demand records, not guaranteed calls.</a:t>
-            </a:r>
-          </a:p>
-          <a:p>
-            <a:pPr marL="285750" indent="-171450">
-              <a:buChar char="•"/>
-            </a:pPr>
-            <a:r>
-              <a:rPr lang="uk-UA" sz="1900" dirty="0">
-                <a:solidFill>
-                  <a:srgbClr val="263244"/>
-                </a:solidFill>
-                <a:latin typeface="Aptos"/>
-                <a:cs typeface="Aptos"/>
-              </a:rPr>
-              <a:t>Operational call-center fields are synthetic and must be presented as assumptions.</a:t>
-            </a:r>
-          </a:p>
-          <a:p>
-            <a:pPr marL="285750" indent="-171450">
-              <a:buChar char="•"/>
-            </a:pPr>
-            <a:r>
-              <a:rPr lang="uk-UA" sz="1900" dirty="0">
-                <a:solidFill>
-                  <a:srgbClr val="263244"/>
-                </a:solidFill>
-                <a:latin typeface="Aptos"/>
-                <a:cs typeface="Aptos"/>
-              </a:rPr>
-              <a:t>Skill-based routing is not yet enforced in the schedule optimizer.</a:t>
-            </a:r>
-          </a:p>
-          <a:p>
-            <a:pPr marL="285750" indent="-171450">
-              <a:buChar char="•"/>
-            </a:pPr>
-            <a:r>
-              <a:rPr lang="uk-UA" sz="1900" dirty="0">
-                <a:solidFill>
-                  <a:srgbClr val="263244"/>
-                </a:solidFill>
-                <a:latin typeface="Aptos"/>
-                <a:cs typeface="Aptos"/>
-              </a:rPr>
-              <a:t>The current SQL Server demo is local rather than cloud-hosted.</a:t>
+              <a:t>The project does not claim to invent WFM as a new market category.</a:t>
+            </a:r>
+          </a:p>
+          <a:p>
+            <a:pPr marL="285750" indent="-171450">
+              <a:buChar char="•"/>
+            </a:pPr>
+            <a:r>
+              <a:rPr lang="uk-UA" sz="1900" dirty="0">
+                <a:solidFill>
+                  <a:srgbClr val="263244"/>
+                </a:solidFill>
+                <a:latin typeface="Aptos"/>
+                <a:cs typeface="Aptos"/>
+              </a:rPr>
+              <a:t>Its novelty is the transparent, reproducible, open-data implementation of an enterprise WFM workflow.</a:t>
+            </a:r>
+          </a:p>
+          <a:p>
+            <a:pPr marL="285750" indent="-171450">
+              <a:buChar char="•"/>
+            </a:pPr>
+            <a:r>
+              <a:rPr lang="uk-UA" sz="1900" dirty="0">
+                <a:solidFill>
+                  <a:srgbClr val="263244"/>
+                </a:solidFill>
+                <a:latin typeface="Aptos"/>
+                <a:cs typeface="Aptos"/>
+              </a:rPr>
+              <a:t>Academic value: every layer can be inspected, changed, evaluated and extended.</a:t>
+            </a:r>
+          </a:p>
+          <a:p>
+            <a:pPr marL="285750" indent="-171450">
+              <a:buChar char="•"/>
+            </a:pPr>
+            <a:r>
+              <a:rPr lang="uk-UA" sz="1900" dirty="0">
+                <a:solidFill>
+                  <a:srgbClr val="263244"/>
+                </a:solidFill>
+                <a:latin typeface="Aptos"/>
+                <a:cs typeface="Aptos"/>
+              </a:rPr>
+              <a:t>Market relevance: commercial WFM suites solve the same real operational problem.</a:t>
             </a:r>
           </a:p>
         </p:txBody>
@@ -1355,7 +1356,7 @@
                 <a:latin typeface="Aptos"/>
                 <a:cs typeface="Aptos"/>
               </a:rPr>
-              <a:t>Future work</a:t>
+              <a:t>Limitations</a:t>
             </a:r>
           </a:p>
         </p:txBody>
@@ -1391,52 +1392,52 @@
                 <a:latin typeface="Aptos"/>
                 <a:cs typeface="Aptos"/>
               </a:rPr>
-              <a:t>Compare Erlang C with Erlang A and discrete-event simulation.</a:t>
-            </a:r>
-          </a:p>
-          <a:p>
-            <a:pPr marL="285750" indent="-171450">
-              <a:buChar char="•"/>
-            </a:pPr>
-            <a:r>
-              <a:rPr lang="uk-UA" sz="1900" dirty="0">
-                <a:solidFill>
-                  <a:srgbClr val="263244"/>
-                </a:solidFill>
-                <a:latin typeface="Aptos"/>
-                <a:cs typeface="Aptos"/>
-              </a:rPr>
-              <a:t>Add intraday re-forecasting and scenario controls.</a:t>
-            </a:r>
-          </a:p>
-          <a:p>
-            <a:pPr marL="285750" indent="-171450">
-              <a:buChar char="•"/>
-            </a:pPr>
-            <a:r>
-              <a:rPr lang="uk-UA" sz="1900" dirty="0">
-                <a:solidFill>
-                  <a:srgbClr val="263244"/>
-                </a:solidFill>
-                <a:latin typeface="Aptos"/>
-                <a:cs typeface="Aptos"/>
-              </a:rPr>
-              <a:t>Extend the optimizer to multi-skill scheduling and agent preferences.</a:t>
-            </a:r>
-          </a:p>
-          <a:p>
-            <a:pPr marL="285750" indent="-171450">
-              <a:buChar char="•"/>
-            </a:pPr>
-            <a:r>
-              <a:rPr lang="uk-UA" sz="1900" dirty="0">
-                <a:solidFill>
-                  <a:srgbClr val="263244"/>
-                </a:solidFill>
-                <a:latin typeface="Aptos"/>
-                <a:cs typeface="Aptos"/>
-              </a:rPr>
-              <a:t>Optional productization: MLflow tracking and portable/cloud-friendly deployment.</a:t>
+              <a:t>311 records are public-service demand records, not guaranteed calls.</a:t>
+            </a:r>
+          </a:p>
+          <a:p>
+            <a:pPr marL="285750" indent="-171450">
+              <a:buChar char="•"/>
+            </a:pPr>
+            <a:r>
+              <a:rPr lang="uk-UA" sz="1900" dirty="0">
+                <a:solidFill>
+                  <a:srgbClr val="263244"/>
+                </a:solidFill>
+                <a:latin typeface="Aptos"/>
+                <a:cs typeface="Aptos"/>
+              </a:rPr>
+              <a:t>Operational call-center fields are synthetic and must be presented as assumptions.</a:t>
+            </a:r>
+          </a:p>
+          <a:p>
+            <a:pPr marL="285750" indent="-171450">
+              <a:buChar char="•"/>
+            </a:pPr>
+            <a:r>
+              <a:rPr lang="uk-UA" sz="1900" dirty="0">
+                <a:solidFill>
+                  <a:srgbClr val="263244"/>
+                </a:solidFill>
+                <a:latin typeface="Aptos"/>
+                <a:cs typeface="Aptos"/>
+              </a:rPr>
+              <a:t>Skill-based routing is not yet enforced in the schedule optimizer.</a:t>
+            </a:r>
+          </a:p>
+          <a:p>
+            <a:pPr marL="285750" indent="-171450">
+              <a:buChar char="•"/>
+            </a:pPr>
+            <a:r>
+              <a:rPr lang="uk-UA" sz="1900" dirty="0">
+                <a:solidFill>
+                  <a:srgbClr val="263244"/>
+                </a:solidFill>
+                <a:latin typeface="Aptos"/>
+                <a:cs typeface="Aptos"/>
+              </a:rPr>
+              <a:t>The public VPS demo uses compact seed tables, not the full SQL Server warehouse.</a:t>
             </a:r>
           </a:p>
         </p:txBody>
@@ -1538,7 +1539,7 @@
                 <a:latin typeface="Aptos"/>
                 <a:cs typeface="Aptos"/>
               </a:rPr>
-              <a:t>Conclusion</a:t>
+              <a:t>Future work</a:t>
             </a:r>
           </a:p>
         </p:txBody>
@@ -1574,37 +1575,52 @@
                 <a:latin typeface="Aptos"/>
                 <a:cs typeface="Aptos"/>
               </a:rPr>
-              <a:t>The project demonstrates a complete path from public demand data to workforce planning decisions.</a:t>
-            </a:r>
-          </a:p>
-          <a:p>
-            <a:pPr marL="285750" indent="-171450">
-              <a:buChar char="•"/>
-            </a:pPr>
-            <a:r>
-              <a:rPr lang="uk-UA" sz="1900" dirty="0">
-                <a:solidFill>
-                  <a:srgbClr val="263244"/>
-                </a:solidFill>
-                <a:latin typeface="Aptos"/>
-                <a:cs typeface="Aptos"/>
-              </a:rPr>
-              <a:t>Implemented layers: SQL warehouse, dashboard, forecasting, staffing and schedule optimization.</a:t>
-            </a:r>
-          </a:p>
-          <a:p>
-            <a:pPr marL="285750" indent="-171450">
-              <a:buChar char="•"/>
-            </a:pPr>
-            <a:r>
-              <a:rPr lang="uk-UA" sz="1900" dirty="0">
-                <a:solidFill>
-                  <a:srgbClr val="263244"/>
-                </a:solidFill>
-                <a:latin typeface="Aptos"/>
-                <a:cs typeface="Aptos"/>
-              </a:rPr>
-              <a:t>The result is a working local analytical product and a defensible capstone engineering artifact.</a:t>
+              <a:t>Compare Erlang C with Erlang A and discrete-event simulation.</a:t>
+            </a:r>
+          </a:p>
+          <a:p>
+            <a:pPr marL="285750" indent="-171450">
+              <a:buChar char="•"/>
+            </a:pPr>
+            <a:r>
+              <a:rPr lang="uk-UA" sz="1900" dirty="0">
+                <a:solidFill>
+                  <a:srgbClr val="263244"/>
+                </a:solidFill>
+                <a:latin typeface="Aptos"/>
+                <a:cs typeface="Aptos"/>
+              </a:rPr>
+              <a:t>Add intraday re-forecasting and scenario controls.</a:t>
+            </a:r>
+          </a:p>
+          <a:p>
+            <a:pPr marL="285750" indent="-171450">
+              <a:buChar char="•"/>
+            </a:pPr>
+            <a:r>
+              <a:rPr lang="uk-UA" sz="1900" dirty="0">
+                <a:solidFill>
+                  <a:srgbClr val="263244"/>
+                </a:solidFill>
+                <a:latin typeface="Aptos"/>
+                <a:cs typeface="Aptos"/>
+              </a:rPr>
+              <a:t>Extend the optimizer to multi-skill scheduling and agent preferences.</a:t>
+            </a:r>
+          </a:p>
+          <a:p>
+            <a:pPr marL="285750" indent="-171450">
+              <a:buChar char="•"/>
+            </a:pPr>
+            <a:r>
+              <a:rPr lang="uk-UA" sz="1900" dirty="0">
+                <a:solidFill>
+                  <a:srgbClr val="263244"/>
+                </a:solidFill>
+                <a:latin typeface="Aptos"/>
+                <a:cs typeface="Aptos"/>
+              </a:rPr>
+              <a:t>Optional productization: MLflow tracking, managed database, monitoring and backups.</a:t>
             </a:r>
           </a:p>
         </p:txBody>
@@ -1639,6 +1655,174 @@
                 <a:cs typeface="Aptos"/>
               </a:rPr>
               <a:t>16</a:t>
+            </a:r>
+          </a:p>
+        </p:txBody>
+      </p:sp>
+    </p:spTree>
+  </p:cSld>
+  <p:clrMapOvr>
+    <a:masterClrMapping/>
+  </p:clrMapOvr>
+</p:sld>
+</file>
+
+<file path=ppt/slides/slide17.xml><?xml version="1.0" encoding="utf-8"?>
+<p:sld xmlns:a="http://schemas.openxmlformats.org/drawingml/2006/main" xmlns:r="http://schemas.openxmlformats.org/officeDocument/2006/relationships" xmlns:p="http://schemas.openxmlformats.org/presentationml/2006/main">
+  <p:cSld>
+    <p:bg>
+      <p:bgPr>
+        <a:solidFill>
+          <a:srgbClr val="ffffff"/>
+        </a:solidFill>
+        <a:effectLst/>
+      </p:bgPr>
+    </p:bg>
+    <p:spTree>
+      <p:nvGrpSpPr>
+        <p:cNvPr id="1" name=""/>
+        <p:cNvGrpSpPr/>
+        <p:nvPr/>
+      </p:nvGrpSpPr>
+      <p:grpSpPr>
+        <a:xfrm>
+          <a:off x="0" y="0"/>
+          <a:ext cx="0" cy="0"/>
+          <a:chOff x="0" y="0"/>
+          <a:chExt cx="0" cy="0"/>
+        </a:xfrm>
+      </p:grpSpPr>
+      <p:sp>
+        <p:nvSpPr>
+          <p:cNvPr id="2" name="Text"/>
+          <p:cNvSpPr txBox="1"/>
+          <p:nvPr/>
+        </p:nvSpPr>
+        <p:spPr>
+          <a:xfrm>
+            <a:off x="620000" y="320000"/>
+            <a:ext cx="12000000" cy="620000"/>
+          </a:xfrm>
+          <a:prstGeom prst="rect">
+            <a:avLst/>
+          </a:prstGeom>
+          <a:noFill/>
+        </p:spPr>
+        <p:txBody>
+          <a:bodyPr wrap="square"/>
+          <a:lstStyle/>
+          <a:p>
+            <a:pPr algn="l"/>
+            <a:r>
+              <a:rPr lang="uk-UA" sz="3100" dirty="0">
+                <a:b/>
+                <a:solidFill>
+                  <a:srgbClr val="111827"/>
+                </a:solidFill>
+                <a:latin typeface="Aptos"/>
+                <a:cs typeface="Aptos"/>
+              </a:rPr>
+              <a:t>Conclusion</a:t>
+            </a:r>
+          </a:p>
+        </p:txBody>
+      </p:sp>
+      <p:sp>
+        <p:nvSpPr>
+          <p:cNvPr id="3" name="Bullets"/>
+          <p:cNvSpPr txBox="1"/>
+          <p:nvPr/>
+        </p:nvSpPr>
+        <p:spPr>
+          <a:xfrm>
+            <a:off x="620000" y="1090000"/>
+            <a:ext cx="11950000" cy="4950000"/>
+          </a:xfrm>
+          <a:prstGeom prst="rect">
+            <a:avLst/>
+          </a:prstGeom>
+          <a:noFill/>
+        </p:spPr>
+        <p:txBody>
+          <a:bodyPr wrap="square"/>
+          <a:lstStyle/>
+          <a:p>
+            <a:pPr marL="285750" indent="-171450">
+              <a:buChar char="•"/>
+            </a:pPr>
+            <a:r>
+              <a:rPr lang="uk-UA" sz="1900" dirty="0">
+                <a:solidFill>
+                  <a:srgbClr val="263244"/>
+                </a:solidFill>
+                <a:latin typeface="Aptos"/>
+                <a:cs typeface="Aptos"/>
+              </a:rPr>
+              <a:t>The project demonstrates a complete path from public demand data to workforce planning decisions.</a:t>
+            </a:r>
+          </a:p>
+          <a:p>
+            <a:pPr marL="285750" indent="-171450">
+              <a:buChar char="•"/>
+            </a:pPr>
+            <a:r>
+              <a:rPr lang="uk-UA" sz="1900" dirty="0">
+                <a:solidFill>
+                  <a:srgbClr val="263244"/>
+                </a:solidFill>
+                <a:latin typeface="Aptos"/>
+                <a:cs typeface="Aptos"/>
+              </a:rPr>
+              <a:t>Implemented layers: SQL warehouse, dashboard, forecasting, staffing and schedule optimization.</a:t>
+            </a:r>
+          </a:p>
+          <a:p>
+            <a:pPr marL="285750" indent="-171450">
+              <a:buChar char="•"/>
+            </a:pPr>
+            <a:r>
+              <a:rPr lang="uk-UA" sz="1900" dirty="0">
+                <a:solidFill>
+                  <a:srgbClr val="263244"/>
+                </a:solidFill>
+                <a:latin typeface="Aptos"/>
+                <a:cs typeface="Aptos"/>
+              </a:rPr>
+              <a:t>The result is a working analytical product, public portfolio demo and defensible capstone engineering artifact.</a:t>
+            </a:r>
+          </a:p>
+        </p:txBody>
+      </p:sp>
+      <p:sp>
+        <p:nvSpPr>
+          <p:cNvPr id="2" name="Text"/>
+          <p:cNvSpPr txBox="1"/>
+          <p:nvPr/>
+        </p:nvSpPr>
+        <p:spPr>
+          <a:xfrm>
+            <a:off x="11880000" y="7050000"/>
+            <a:ext cx="820000" cy="240000"/>
+          </a:xfrm>
+          <a:prstGeom prst="rect">
+            <a:avLst/>
+          </a:prstGeom>
+          <a:noFill/>
+        </p:spPr>
+        <p:txBody>
+          <a:bodyPr wrap="square"/>
+          <a:lstStyle/>
+          <a:p>
+            <a:pPr algn="r"/>
+            <a:r>
+              <a:rPr lang="uk-UA" sz="1150" dirty="0">
+                <a:solidFill>
+                  <a:srgbClr val="9ca3af"/>
+                </a:solidFill>
+                <a:latin typeface="Aptos"/>
+                <a:cs typeface="Aptos"/>
+              </a:rPr>
+              <a:t>17</a:t>
             </a:r>
           </a:p>
         </p:txBody>

</xml_diff>